<commit_message>
Improve KPI card metric labeling
</commit_message>
<xml_diff>
--- a/reports/Presentation.pptx
+++ b/reports/Presentation.pptx
@@ -299,7 +299,7 @@
           <a:p>
             <a:fld id="{1D4FEFF0-A8FF-418B-91C8-254DB0D5C9F7}" type="datetimeFigureOut">
               <a:rPr lang="en-IN" smtClean="0"/>
-              <a:t>12-08-2026</a:t>
+              <a:t>24-08-2026</a:t>
             </a:fld>
             <a:endParaRPr lang="en-IN"/>
           </a:p>
@@ -469,7 +469,7 @@
           <a:p>
             <a:fld id="{1D4FEFF0-A8FF-418B-91C8-254DB0D5C9F7}" type="datetimeFigureOut">
               <a:rPr lang="en-IN" smtClean="0"/>
-              <a:t>12-08-2026</a:t>
+              <a:t>24-08-2026</a:t>
             </a:fld>
             <a:endParaRPr lang="en-IN"/>
           </a:p>
@@ -692,7 +692,7 @@
           <a:p>
             <a:fld id="{1D4FEFF0-A8FF-418B-91C8-254DB0D5C9F7}" type="datetimeFigureOut">
               <a:rPr lang="en-IN" smtClean="0"/>
-              <a:t>12-08-2026</a:t>
+              <a:t>24-08-2026</a:t>
             </a:fld>
             <a:endParaRPr lang="en-IN"/>
           </a:p>
@@ -872,7 +872,7 @@
           <a:p>
             <a:fld id="{1D4FEFF0-A8FF-418B-91C8-254DB0D5C9F7}" type="datetimeFigureOut">
               <a:rPr lang="en-IN" smtClean="0"/>
-              <a:t>12-08-2026</a:t>
+              <a:t>24-08-2026</a:t>
             </a:fld>
             <a:endParaRPr lang="en-IN"/>
           </a:p>
@@ -1178,7 +1178,7 @@
           <a:p>
             <a:fld id="{1D4FEFF0-A8FF-418B-91C8-254DB0D5C9F7}" type="datetimeFigureOut">
               <a:rPr lang="en-IN" smtClean="0"/>
-              <a:t>12-08-2026</a:t>
+              <a:t>24-08-2026</a:t>
             </a:fld>
             <a:endParaRPr lang="en-IN"/>
           </a:p>
@@ -1482,7 +1482,7 @@
           <a:p>
             <a:fld id="{1D4FEFF0-A8FF-418B-91C8-254DB0D5C9F7}" type="datetimeFigureOut">
               <a:rPr lang="en-IN" smtClean="0"/>
-              <a:t>12-08-2026</a:t>
+              <a:t>24-08-2026</a:t>
             </a:fld>
             <a:endParaRPr lang="en-IN"/>
           </a:p>
@@ -1904,7 +1904,7 @@
           <a:p>
             <a:fld id="{1D4FEFF0-A8FF-418B-91C8-254DB0D5C9F7}" type="datetimeFigureOut">
               <a:rPr lang="en-IN" smtClean="0"/>
-              <a:t>12-08-2026</a:t>
+              <a:t>24-08-2026</a:t>
             </a:fld>
             <a:endParaRPr lang="en-IN"/>
           </a:p>
@@ -2022,7 +2022,7 @@
           <a:p>
             <a:fld id="{1D4FEFF0-A8FF-418B-91C8-254DB0D5C9F7}" type="datetimeFigureOut">
               <a:rPr lang="en-IN" smtClean="0"/>
-              <a:t>12-08-2026</a:t>
+              <a:t>24-08-2026</a:t>
             </a:fld>
             <a:endParaRPr lang="en-IN"/>
           </a:p>
@@ -2117,7 +2117,7 @@
           <a:p>
             <a:fld id="{1D4FEFF0-A8FF-418B-91C8-254DB0D5C9F7}" type="datetimeFigureOut">
               <a:rPr lang="en-IN" smtClean="0"/>
-              <a:t>12-08-2026</a:t>
+              <a:t>24-08-2026</a:t>
             </a:fld>
             <a:endParaRPr lang="en-IN"/>
           </a:p>
@@ -2390,7 +2390,7 @@
           <a:p>
             <a:fld id="{1D4FEFF0-A8FF-418B-91C8-254DB0D5C9F7}" type="datetimeFigureOut">
               <a:rPr lang="en-IN" smtClean="0"/>
-              <a:t>12-08-2026</a:t>
+              <a:t>24-08-2026</a:t>
             </a:fld>
             <a:endParaRPr lang="en-IN"/>
           </a:p>
@@ -2655,7 +2655,7 @@
           <a:p>
             <a:fld id="{1D4FEFF0-A8FF-418B-91C8-254DB0D5C9F7}" type="datetimeFigureOut">
               <a:rPr lang="en-IN" smtClean="0"/>
-              <a:t>12-08-2026</a:t>
+              <a:t>24-08-2026</a:t>
             </a:fld>
             <a:endParaRPr lang="en-IN"/>
           </a:p>
@@ -2904,7 +2904,7 @@
           <a:p>
             <a:fld id="{1D4FEFF0-A8FF-418B-91C8-254DB0D5C9F7}" type="datetimeFigureOut">
               <a:rPr lang="en-IN" smtClean="0"/>
-              <a:t>12-08-2026</a:t>
+              <a:t>24-08-2026</a:t>
             </a:fld>
             <a:endParaRPr lang="en-IN"/>
           </a:p>
@@ -3382,16 +3382,8 @@
           <a:lstStyle/>
           <a:p>
             <a:r>
-              <a:rPr lang="en-IN" sz="2000" b="1" dirty="0" err="1" smtClean="0"/>
-              <a:t>Bluestock</a:t>
-            </a:r>
-            <a:r>
               <a:rPr lang="en-IN" sz="2000" b="1" dirty="0" smtClean="0"/>
-              <a:t> Mutual Fund </a:t>
-            </a:r>
-            <a:r>
-              <a:rPr lang="en-IN" sz="2000" b="1" dirty="0" smtClean="0"/>
-              <a:t>Analytics</a:t>
+              <a:t>Bluestock Mutual Fund Analytics</a:t>
             </a:r>
             <a:endParaRPr lang="en-IN" sz="2000" dirty="0"/>
           </a:p>
@@ -3546,7 +3538,6 @@
               <a:rPr lang="en-IN" dirty="0"/>
               <a:t>Fund Performance Dashboard</a:t>
             </a:r>
-            <a:endParaRPr lang="en-IN" dirty="0"/>
           </a:p>
         </p:txBody>
       </p:sp>
@@ -5323,11 +5314,7 @@
             </a:r>
             <a:r>
               <a:rPr lang="en-IN" dirty="0" smtClean="0"/>
-              <a:t>: </a:t>
-            </a:r>
-            <a:r>
-              <a:rPr lang="en-IN" dirty="0" smtClean="0"/>
-              <a:t>Investor &amp; SIP</a:t>
+              <a:t>: Investor &amp; SIP</a:t>
             </a:r>
             <a:endParaRPr lang="en-IN" dirty="0"/>
           </a:p>
@@ -5603,11 +5590,6 @@
               </a:rPr>
               <a:t> Median SIP contributions are consistent across age groups at approximately ₹5,000-₹5,420, with high-value outliers approaching ₹60,000.</a:t>
             </a:r>
-            <a:endParaRPr lang="en-US" dirty="0">
-              <a:latin typeface="Calibri" panose="020F0502020204030204" pitchFamily="34" charset="0"/>
-              <a:ea typeface="Calibri" panose="020F0502020204030204" pitchFamily="34" charset="0"/>
-              <a:cs typeface="Calibri" panose="020F0502020204030204" pitchFamily="34" charset="0"/>
-            </a:endParaRPr>
           </a:p>
         </p:txBody>
       </p:sp>
@@ -6250,8 +6232,8 @@
         </p:blipFill>
         <p:spPr>
           <a:xfrm>
-            <a:off x="1603782" y="2031024"/>
-            <a:ext cx="8982353" cy="4615961"/>
+            <a:off x="1969808" y="2031024"/>
+            <a:ext cx="8250300" cy="4615961"/>
           </a:xfrm>
           <a:prstGeom prst="roundRect">
             <a:avLst>

</xml_diff>